<commit_message>
fix(pptx): Oracle_DB_Migration_Guide — sectionLst GUID 형식 수정
p14:section id가 {B0000001} 형식(비표준)으로 생성되어 PowerPoint Repair
다이얼로그 발생. 표준 UUID v4 형식으로 4개 섹션 ID 교체.

Co-Authored-By: Claude Sonnet 4.6 <noreply@anthropic.com>
</commit_message>
<xml_diff>
--- a/results/pptx/Oracle_DB_Migration_Guide.pptx
+++ b/results/pptx/Oracle_DB_Migration_Guide.pptx
@@ -122,17 +122,17 @@
   <p:extLst>
     <p:ext uri="{521415D9-36F7-43E2-AB2F-B90AF26B5E84}">
       <p14:sectionLst xmlns:p14="http://schemas.microsoft.com/office/powerpoint/2010/main">
-        <p14:section name="표지" id="{B0000001}">
+        <p14:section name="표지" id="{7321E9E0-4414-48B6-928B-2A781DDB42F0}">
           <p14:sldIdLst>
             <p14:sldId id="500"/>
           </p14:sldIdLst>
         </p14:section>
-        <p14:section name="목차" id="{B0000002}">
+        <p14:section name="목차" id="{9E3BB65B-53F3-4329-A82D-DADCE5A569AE}">
           <p14:sldIdLst>
             <p14:sldId id="501"/>
           </p14:sldIdLst>
         </p14:section>
-        <p14:section name="본문" id="{B0000003}">
+        <p14:section name="본문" id="{B8ABE98F-39ED-4A3A-B3C3-4BEA4EB45FBA}">
           <p14:sldIdLst>
             <p14:sldId id="502"/>
             <p14:sldId id="503"/>
@@ -143,7 +143,7 @@
             <p14:sldId id="508"/>
           </p14:sldIdLst>
         </p14:section>
-        <p14:section name="끝맺음" id="{B0000004}">
+        <p14:section name="끝맺음" id="{DBD35560-5944-4083-9EED-3AC03737B5AF}">
           <p14:sldIdLst>
             <p14:sldId id="509"/>
           </p14:sldIdLst>

</xml_diff>

<commit_message>
fix(pptx): 표지 제목 폰트 50pt→36pt 축소
"Oracle DB 마이그레이션" 6Korean+9ASCII at 50pt이 TextBox 5.9" 폭 초과,
3줄 렌더링으로 소제목(TextBox 25)과 겹침. 36pt로 조정하여 2줄 내 수용.

Co-Authored-By: Claude Sonnet 4.6 <noreply@anthropic.com>
</commit_message>
<xml_diff>
--- a/results/pptx/Oracle_DB_Migration_Guide.pptx
+++ b/results/pptx/Oracle_DB_Migration_Guide.pptx
@@ -2974,7 +2974,7 @@
           <a:p>
             <a:pPr latinLnBrk="0"/>
             <a:r>
-              <a:rPr lang="en-US" altLang="ko-KR" sz="5000" dirty="0">
+              <a:rPr lang="en-US" altLang="ko-KR" sz="3600" dirty="0">
                 <a:ln>
                   <a:solidFill>
                     <a:schemeClr val="accent1">
@@ -2995,7 +2995,7 @@
           <a:p>
             <a:pPr latinLnBrk="0"/>
             <a:r>
-              <a:rPr lang="en-US" altLang="ko-KR" sz="5000" dirty="0">
+              <a:rPr lang="en-US" altLang="ko-KR" sz="3600" dirty="0">
                 <a:ln>
                   <a:solidFill>
                     <a:schemeClr val="accent1">

</xml_diff>